<commit_message>
feat: implement System 1/System 2 dual-model architecture with Jev and Llama 3
</commit_message>
<xml_diff>
--- a/25ARE471_Introd_to_GenAI_CB.EN.U4ARE23023.pptx
+++ b/25ARE471_Introd_to_GenAI_CB.EN.U4ARE23023.pptx
@@ -3136,7 +3136,7 @@
               </a:defRPr>
             </a:pPr>
             <a:r>
-              <a:t>AI Delivery Manager</a:t>
+              <a:t>AI Engineering Delivery Manager</a:t>
             </a:r>
           </a:p>
           <a:p>
@@ -4485,7 +4485,7 @@
                         </a:defRPr>
                       </a:pPr>
                       <a:r>
-                        <a:t>GenAI Workflow (AI Delivery Manager)</a:t>
+                        <a:t>GenAI Workflow (AI Engineering Delivery Manager)</a:t>
                       </a:r>
                     </a:p>
                   </a:txBody>

</xml_diff>